<commit_message>
:memo: adds figures on day4
</commit_message>
<xml_diff>
--- a/site-assets/sources/day4/fig-ja-en.pptx
+++ b/site-assets/sources/day4/fig-ja-en.pptx
@@ -5,21 +5,21 @@
     <p:sldMasterId id="2147483660" r:id="rId1"/>
   </p:sldMasterIdLst>
   <p:notesMasterIdLst>
-    <p:notesMasterId r:id="rId8"/>
+    <p:notesMasterId r:id="rId14"/>
   </p:notesMasterIdLst>
   <p:sldIdLst>
     <p:sldId id="256" r:id="rId2"/>
-    <p:sldId id="262" r:id="rId13"/>
-    <p:sldId id="257" r:id="rId3"/>
-    <p:sldId id="263" r:id="rId14"/>
-    <p:sldId id="258" r:id="rId4"/>
-    <p:sldId id="264" r:id="rId15"/>
-    <p:sldId id="260" r:id="rId5"/>
-    <p:sldId id="265" r:id="rId16"/>
-    <p:sldId id="259" r:id="rId6"/>
-    <p:sldId id="266" r:id="rId17"/>
-    <p:sldId id="261" r:id="rId7"/>
-    <p:sldId id="267" r:id="rId18"/>
+    <p:sldId id="262" r:id="rId3"/>
+    <p:sldId id="257" r:id="rId4"/>
+    <p:sldId id="263" r:id="rId5"/>
+    <p:sldId id="258" r:id="rId6"/>
+    <p:sldId id="264" r:id="rId7"/>
+    <p:sldId id="260" r:id="rId8"/>
+    <p:sldId id="265" r:id="rId9"/>
+    <p:sldId id="259" r:id="rId10"/>
+    <p:sldId id="266" r:id="rId11"/>
+    <p:sldId id="261" r:id="rId12"/>
+    <p:sldId id="267" r:id="rId13"/>
   </p:sldIdLst>
   <p:sldSz cx="9906000" cy="6858000" type="A4"/>
   <p:notesSz cx="6858000" cy="9144000"/>
@@ -210,7 +210,7 @@
           </a:lstStyle>
           <a:p>
             <a:fld id="{234B1B89-6D29-7849-8E65-921CEBC6CA4C}" type="datetimeFigureOut">
-              <a:t>2018/10/29</a:t>
+              <a:t>2026/8/7</a:t>
             </a:fld>
             <a:endParaRPr kumimoji="1" lang="ja-JP" altLang="en-US"/>
           </a:p>
@@ -2144,42 +2144,6 @@
       </p:grpSpPr>
       <p:sp>
         <p:nvSpPr>
-          <p:cNvPr id="2" name="テキスト ボックス 1">
-            <a:extLst>
-              <a:ext uri="{FF2B5EF4-FFF2-40B4-BE49-F238E27FC236}">
-                <a16:creationId xmlns:a16="http://schemas.microsoft.com/office/drawing/2014/main" id="{66C462CB-E053-B946-8270-83001F55D617}"/>
-              </a:ext>
-            </a:extLst>
-          </p:cNvPr>
-          <p:cNvSpPr txBox="1"/>
-          <p:nvPr/>
-        </p:nvSpPr>
-        <p:spPr>
-          <a:xfrm>
-            <a:off x="2113280" y="254000"/>
-            <a:ext cx="5109091" cy="461665"/>
-          </a:xfrm>
-          <a:prstGeom prst="rect">
-            <a:avLst/>
-          </a:prstGeom>
-          <a:noFill/>
-        </p:spPr>
-        <p:txBody>
-          <a:bodyPr wrap="square" rtlCol="0"/>
-          <a:lstStyle/>
-          <a:p>
-            <a:pPr>
-              <a:defRPr sz="1750"/>
-            </a:pPr>
-            <a:r>
-              <a:rPr kumimoji="1" lang="ja-JP" altLang="en-US" sz="1750"/>
-              <a:t>Ways for a parallel program to write files</a:t>
-            </a:r>
-          </a:p>
-        </p:txBody>
-      </p:sp>
-      <p:sp>
-        <p:nvSpPr>
           <p:cNvPr id="3" name="テキスト ボックス 2">
             <a:extLst>
               <a:ext uri="{FF2B5EF4-FFF2-40B4-BE49-F238E27FC236}">
@@ -2210,7 +2174,7 @@
               <a:defRPr/>
             </a:pPr>
             <a:r>
-              <a:rPr kumimoji="1" lang="en-US" altLang="ja-JP"/>
+              <a:rPr kumimoji="1" lang="en-US" altLang="ja-JP" dirty="0"/>
               <a:t>1. Each process writes independently</a:t>
             </a:r>
           </a:p>
@@ -2299,11 +2263,6 @@
                 </a:rPr>
                 <a:t>Process 1</a:t>
               </a:r>
-              <a:endParaRPr kumimoji="1" lang="ja-JP" altLang="en-US" sz="1200">
-                <a:solidFill>
-                  <a:schemeClr val="tx1"/>
-                </a:solidFill>
-              </a:endParaRPr>
             </a:p>
           </p:txBody>
         </p:sp>
@@ -2491,11 +2450,6 @@
                 </a:rPr>
                 <a:t>Process 2</a:t>
               </a:r>
-              <a:endParaRPr kumimoji="1" lang="ja-JP" altLang="en-US" sz="1200">
-                <a:solidFill>
-                  <a:schemeClr val="tx1"/>
-                </a:solidFill>
-              </a:endParaRPr>
             </a:p>
           </p:txBody>
         </p:sp>
@@ -2683,11 +2637,6 @@
                 </a:rPr>
                 <a:t>Process 3</a:t>
               </a:r>
-              <a:endParaRPr kumimoji="1" lang="ja-JP" altLang="en-US" sz="1200">
-                <a:solidFill>
-                  <a:schemeClr val="tx1"/>
-                </a:solidFill>
-              </a:endParaRPr>
             </a:p>
           </p:txBody>
         </p:sp>
@@ -2875,11 +2824,6 @@
                 </a:rPr>
                 <a:t>Process 4</a:t>
               </a:r>
-              <a:endParaRPr kumimoji="1" lang="ja-JP" altLang="en-US" sz="1200">
-                <a:solidFill>
-                  <a:schemeClr val="tx1"/>
-                </a:solidFill>
-              </a:endParaRPr>
             </a:p>
           </p:txBody>
         </p:sp>
@@ -3058,7 +3002,7 @@
         </p:nvSpPr>
         <p:spPr>
           <a:xfrm>
-            <a:off x="731520" y="4927600"/>
+            <a:off x="731520" y="4958515"/>
             <a:ext cx="2031325" cy="369332"/>
           </a:xfrm>
           <a:prstGeom prst="rect">
@@ -3084,53 +3028,6 @@
       </p:sp>
       <p:sp>
         <p:nvSpPr>
-          <p:cNvPr id="31" name="テキスト ボックス 30">
-            <a:extLst>
-              <a:ext uri="{FF2B5EF4-FFF2-40B4-BE49-F238E27FC236}">
-                <a16:creationId xmlns:a16="http://schemas.microsoft.com/office/drawing/2014/main" id="{ABFAA4F4-D26C-2549-831D-910EC8663E6D}"/>
-              </a:ext>
-            </a:extLst>
-          </p:cNvPr>
-          <p:cNvSpPr txBox="1"/>
-          <p:nvPr/>
-        </p:nvSpPr>
-        <p:spPr>
-          <a:xfrm>
-            <a:off x="619760" y="5740400"/>
-            <a:ext cx="2518638" cy="523220"/>
-          </a:xfrm>
-          <a:prstGeom prst="rect">
-            <a:avLst/>
-          </a:prstGeom>
-          <a:noFill/>
-        </p:spPr>
-        <p:txBody>
-          <a:bodyPr wrap="square" rtlCol="0"/>
-          <a:lstStyle/>
-          <a:p>
-            <a:pPr>
-              <a:defRPr sz="1000"/>
-            </a:pPr>
-            <a:r>
-              <a:rPr kumimoji="1" lang="ja-JP" altLang="en-US" sz="1000"/>
-              <a:t>A large number of files are output:</a:t>
-            </a:r>
-            <a:endParaRPr lang="en-US" altLang="ja-JP" sz="1400"/>
-          </a:p>
-          <a:p>
-            <a:pPr>
-              <a:defRPr sz="1000"/>
-            </a:pPr>
-            <a:r>
-              <a:rPr kumimoji="1" lang="ja-JP" altLang="en-US" sz="1000"/>
-              <a:t>steps x processes</a:t>
-            </a:r>
-            <a:endParaRPr lang="en-US" altLang="ja-JP" sz="1400"/>
-          </a:p>
-        </p:txBody>
-      </p:sp>
-      <p:sp>
-        <p:nvSpPr>
           <p:cNvPr id="32" name="テキスト ボックス 31">
             <a:extLst>
               <a:ext uri="{FF2B5EF4-FFF2-40B4-BE49-F238E27FC236}">
@@ -3159,10 +3056,10 @@
               <a:defRPr sz="1500"/>
             </a:pPr>
             <a:r>
-              <a:rPr kumimoji="1" lang="en-US" altLang="ja-JP" sz="1500"/>
+              <a:rPr kumimoji="1" lang="en-US" altLang="ja-JP" sz="1500" dirty="0"/>
               <a:t>2. Append to a single file</a:t>
             </a:r>
-            <a:endParaRPr kumimoji="1" lang="en-US" altLang="ja-JP"/>
+            <a:endParaRPr kumimoji="1" lang="en-US" altLang="ja-JP" dirty="0"/>
           </a:p>
         </p:txBody>
       </p:sp>
@@ -3229,11 +3126,6 @@
               </a:rPr>
               <a:t>Process 1</a:t>
             </a:r>
-            <a:endParaRPr kumimoji="1" lang="ja-JP" altLang="en-US" sz="1200">
-              <a:solidFill>
-                <a:schemeClr val="tx1"/>
-              </a:solidFill>
-            </a:endParaRPr>
           </a:p>
         </p:txBody>
       </p:sp>
@@ -3400,11 +3292,6 @@
               </a:rPr>
               <a:t>Process 2</a:t>
             </a:r>
-            <a:endParaRPr kumimoji="1" lang="ja-JP" altLang="en-US" sz="1200">
-              <a:solidFill>
-                <a:schemeClr val="tx1"/>
-              </a:solidFill>
-            </a:endParaRPr>
           </a:p>
         </p:txBody>
       </p:sp>
@@ -3471,11 +3358,6 @@
               </a:rPr>
               <a:t>Process 3</a:t>
             </a:r>
-            <a:endParaRPr kumimoji="1" lang="ja-JP" altLang="en-US" sz="1200">
-              <a:solidFill>
-                <a:schemeClr val="tx1"/>
-              </a:solidFill>
-            </a:endParaRPr>
           </a:p>
         </p:txBody>
       </p:sp>
@@ -3542,11 +3424,6 @@
               </a:rPr>
               <a:t>Process 4</a:t>
             </a:r>
-            <a:endParaRPr kumimoji="1" lang="ja-JP" altLang="en-US" sz="1200">
-              <a:solidFill>
-                <a:schemeClr val="tx1"/>
-              </a:solidFill>
-            </a:endParaRPr>
           </a:p>
         </p:txBody>
       </p:sp>
@@ -3756,7 +3633,7 @@
         </p:nvSpPr>
         <p:spPr>
           <a:xfrm>
-            <a:off x="4033520" y="5019040"/>
+            <a:off x="4003040" y="5019040"/>
             <a:ext cx="1620957" cy="307777"/>
           </a:xfrm>
           <a:prstGeom prst="rect">
@@ -3877,10 +3754,10 @@
               <a:defRPr sz="1500"/>
             </a:pPr>
             <a:r>
-              <a:rPr kumimoji="1" lang="en-US" altLang="ja-JP" sz="1500"/>
+              <a:rPr kumimoji="1" lang="en-US" altLang="ja-JP" sz="1500" dirty="0"/>
               <a:t>3. Gather once, then write</a:t>
             </a:r>
-            <a:endParaRPr kumimoji="1" lang="en-US" altLang="ja-JP"/>
+            <a:endParaRPr kumimoji="1" lang="en-US" altLang="ja-JP" dirty="0"/>
           </a:p>
         </p:txBody>
       </p:sp>
@@ -3947,11 +3824,6 @@
               </a:rPr>
               <a:t>Process 1</a:t>
             </a:r>
-            <a:endParaRPr kumimoji="1" lang="ja-JP" altLang="en-US" sz="1200">
-              <a:solidFill>
-                <a:schemeClr val="tx1"/>
-              </a:solidFill>
-            </a:endParaRPr>
           </a:p>
         </p:txBody>
       </p:sp>
@@ -4064,11 +3936,6 @@
               </a:rPr>
               <a:t>Process 2</a:t>
             </a:r>
-            <a:endParaRPr kumimoji="1" lang="ja-JP" altLang="en-US" sz="1200">
-              <a:solidFill>
-                <a:schemeClr val="tx1"/>
-              </a:solidFill>
-            </a:endParaRPr>
           </a:p>
         </p:txBody>
       </p:sp>
@@ -4135,11 +4002,6 @@
               </a:rPr>
               <a:t>Process 3</a:t>
             </a:r>
-            <a:endParaRPr kumimoji="1" lang="ja-JP" altLang="en-US" sz="1200">
-              <a:solidFill>
-                <a:schemeClr val="tx1"/>
-              </a:solidFill>
-            </a:endParaRPr>
           </a:p>
         </p:txBody>
       </p:sp>
@@ -4206,11 +4068,6 @@
               </a:rPr>
               <a:t>Process 4</a:t>
             </a:r>
-            <a:endParaRPr kumimoji="1" lang="ja-JP" altLang="en-US" sz="1200">
-              <a:solidFill>
-                <a:schemeClr val="tx1"/>
-              </a:solidFill>
-            </a:endParaRPr>
           </a:p>
         </p:txBody>
       </p:sp>
@@ -4460,53 +4317,6 @@
           </a:prstGeom>
         </p:spPr>
       </p:pic>
-      <p:sp>
-        <p:nvSpPr>
-          <p:cNvPr id="60" name="テキスト ボックス 59">
-            <a:extLst>
-              <a:ext uri="{FF2B5EF4-FFF2-40B4-BE49-F238E27FC236}">
-                <a16:creationId xmlns:a16="http://schemas.microsoft.com/office/drawing/2014/main" id="{1CA11D8F-C2E5-A04A-BEB7-51298B052C70}"/>
-              </a:ext>
-            </a:extLst>
-          </p:cNvPr>
-          <p:cNvSpPr txBox="1"/>
-          <p:nvPr/>
-        </p:nvSpPr>
-        <p:spPr>
-          <a:xfrm>
-            <a:off x="7294880" y="4876800"/>
-            <a:ext cx="2159566" cy="523220"/>
-          </a:xfrm>
-          <a:prstGeom prst="rect">
-            <a:avLst/>
-          </a:prstGeom>
-          <a:noFill/>
-        </p:spPr>
-        <p:txBody>
-          <a:bodyPr wrap="square" rtlCol="0"/>
-          <a:lstStyle/>
-          <a:p>
-            <a:pPr>
-              <a:defRPr sz="1100"/>
-            </a:pPr>
-            <a:r>
-              <a:rPr kumimoji="1" lang="ja-JP" altLang="en-US" sz="1100"/>
-              <a:t>File output is gathered</a:t>
-            </a:r>
-            <a:endParaRPr kumimoji="1" lang="en-US" altLang="ja-JP" sz="1400"/>
-          </a:p>
-          <a:p>
-            <a:pPr>
-              <a:defRPr sz="1100"/>
-            </a:pPr>
-            <a:r>
-              <a:rPr kumimoji="1" lang="ja-JP" altLang="en-US" sz="1100"/>
-              <a:t>and done once, so it is fast</a:t>
-            </a:r>
-            <a:endParaRPr kumimoji="1" lang="en-US" altLang="ja-JP" sz="1400"/>
-          </a:p>
-        </p:txBody>
-      </p:sp>
       <p:pic>
         <p:nvPicPr>
           <p:cNvPr id="61" name="図 60">
@@ -4551,7 +4361,7 @@
         </p:nvSpPr>
         <p:spPr>
           <a:xfrm>
-            <a:off x="7355840" y="5720080"/>
+            <a:off x="7340377" y="5720080"/>
             <a:ext cx="1620957" cy="307777"/>
           </a:xfrm>
           <a:prstGeom prst="rect">
@@ -4571,6 +4381,123 @@
             <a:r>
               <a:rPr kumimoji="1" lang="ja-JP" altLang="en-US" sz="1400"/>
               <a:t>Consumes memory</a:t>
+            </a:r>
+          </a:p>
+        </p:txBody>
+      </p:sp>
+      <p:sp>
+        <p:nvSpPr>
+          <p:cNvPr id="6" name="テキスト ボックス 5">
+            <a:extLst>
+              <a:ext uri="{FF2B5EF4-FFF2-40B4-BE49-F238E27FC236}">
+                <a16:creationId xmlns:a16="http://schemas.microsoft.com/office/drawing/2014/main" id="{026C3B8E-3C52-6B4B-49D0-8BED0A094F3F}"/>
+              </a:ext>
+            </a:extLst>
+          </p:cNvPr>
+          <p:cNvSpPr txBox="1"/>
+          <p:nvPr/>
+        </p:nvSpPr>
+        <p:spPr>
+          <a:xfrm>
+            <a:off x="2196371" y="293023"/>
+            <a:ext cx="5513258" cy="461665"/>
+          </a:xfrm>
+          <a:prstGeom prst="rect">
+            <a:avLst/>
+          </a:prstGeom>
+          <a:noFill/>
+        </p:spPr>
+        <p:txBody>
+          <a:bodyPr wrap="square">
+            <a:spAutoFit/>
+          </a:bodyPr>
+          <a:lstStyle/>
+          <a:p>
+            <a:r>
+              <a:rPr lang="ja-JP" altLang="en-US" sz="2400"/>
+              <a:t>Ways for a parallel program to write files</a:t>
+            </a:r>
+          </a:p>
+        </p:txBody>
+      </p:sp>
+      <p:sp>
+        <p:nvSpPr>
+          <p:cNvPr id="8" name="テキスト ボックス 7">
+            <a:extLst>
+              <a:ext uri="{FF2B5EF4-FFF2-40B4-BE49-F238E27FC236}">
+                <a16:creationId xmlns:a16="http://schemas.microsoft.com/office/drawing/2014/main" id="{55DC9FAD-734C-E050-CEC0-D7EF2247412F}"/>
+              </a:ext>
+            </a:extLst>
+          </p:cNvPr>
+          <p:cNvSpPr txBox="1"/>
+          <p:nvPr/>
+        </p:nvSpPr>
+        <p:spPr>
+          <a:xfrm>
+            <a:off x="731520" y="5730435"/>
+            <a:ext cx="2377440" cy="461665"/>
+          </a:xfrm>
+          <a:prstGeom prst="rect">
+            <a:avLst/>
+          </a:prstGeom>
+          <a:noFill/>
+        </p:spPr>
+        <p:txBody>
+          <a:bodyPr wrap="square">
+            <a:spAutoFit/>
+          </a:bodyPr>
+          <a:lstStyle/>
+          <a:p>
+            <a:r>
+              <a:rPr lang="ja-JP" altLang="en-US" sz="1200"/>
+              <a:t>A large number of files are output:</a:t>
+            </a:r>
+          </a:p>
+          <a:p>
+            <a:r>
+              <a:rPr lang="ja-JP" altLang="en-US" sz="1200"/>
+              <a:t>steps x processes</a:t>
+            </a:r>
+          </a:p>
+        </p:txBody>
+      </p:sp>
+      <p:sp>
+        <p:nvSpPr>
+          <p:cNvPr id="12" name="テキスト ボックス 11">
+            <a:extLst>
+              <a:ext uri="{FF2B5EF4-FFF2-40B4-BE49-F238E27FC236}">
+                <a16:creationId xmlns:a16="http://schemas.microsoft.com/office/drawing/2014/main" id="{F4F7AA1F-677A-41DD-BCBB-CC530CC0E828}"/>
+              </a:ext>
+            </a:extLst>
+          </p:cNvPr>
+          <p:cNvSpPr txBox="1"/>
+          <p:nvPr/>
+        </p:nvSpPr>
+        <p:spPr>
+          <a:xfrm>
+            <a:off x="7340377" y="4942095"/>
+            <a:ext cx="2001356" cy="461665"/>
+          </a:xfrm>
+          <a:prstGeom prst="rect">
+            <a:avLst/>
+          </a:prstGeom>
+          <a:noFill/>
+        </p:spPr>
+        <p:txBody>
+          <a:bodyPr wrap="square">
+            <a:spAutoFit/>
+          </a:bodyPr>
+          <a:lstStyle/>
+          <a:p>
+            <a:r>
+              <a:rPr lang="ja-JP" altLang="en-US" sz="1200"/>
+              <a:t>File output is gathered</a:t>
+            </a:r>
+          </a:p>
+          <a:p>
+            <a:r>
+              <a:rPr lang="ja-JP" altLang="en-US" sz="1200"/>
+              <a:t>and done once, so it is fast</a:t>
             </a:r>
           </a:p>
         </p:txBody>
@@ -5613,13 +5540,13 @@
         </p:nvSpPr>
         <p:spPr>
           <a:xfrm>
-            <a:off x="920552" y="1196752"/>
-            <a:ext cx="2448272" cy="648072"/>
+            <a:off x="524508" y="1381191"/>
+            <a:ext cx="3240360" cy="494763"/>
           </a:xfrm>
           <a:prstGeom prst="wedgeRectCallout">
             <a:avLst>
-              <a:gd name="adj1" fmla="val -43358"/>
-              <a:gd name="adj2" fmla="val 101066"/>
+              <a:gd name="adj1" fmla="val -34365"/>
+              <a:gd name="adj2" fmla="val 113252"/>
             </a:avLst>
           </a:prstGeom>
           <a:noFill/>
@@ -5779,7 +5706,7 @@
           </a:fontRef>
         </p:style>
         <p:txBody>
-          <a:bodyPr rtlCol="0" anchor="ctr" wrap="square"/>
+          <a:bodyPr wrap="square" rtlCol="0" anchor="ctr"/>
           <a:lstStyle/>
           <a:p>
             <a:pPr algn="ctr">
@@ -5865,8 +5792,8 @@
         </p:nvSpPr>
         <p:spPr>
           <a:xfrm>
-            <a:off x="1352600" y="692696"/>
-            <a:ext cx="1800493" cy="369332"/>
+            <a:off x="1568624" y="702288"/>
+            <a:ext cx="1224136" cy="369332"/>
           </a:xfrm>
           <a:prstGeom prst="rect">
             <a:avLst/>
@@ -5881,7 +5808,7 @@
           </a:ln>
         </p:spPr>
         <p:txBody>
-          <a:bodyPr wrap="none" rtlCol="0">
+          <a:bodyPr wrap="square" rtlCol="0">
             <a:spAutoFit/>
           </a:bodyPr>
           <a:lstStyle/>
@@ -5940,49 +5867,12 @@
           </a:fontRef>
         </p:style>
       </p:cxnSp>
-      <p:sp>
-        <p:nvSpPr>
-          <p:cNvPr id="16" name="テキスト ボックス 15">
-            <a:extLst>
-              <a:ext uri="{FF2B5EF4-FFF2-40B4-BE49-F238E27FC236}">
-                <a16:creationId xmlns:a16="http://schemas.microsoft.com/office/drawing/2014/main" id="{B96C22D3-9F05-D04B-8811-AC1690B44560}"/>
-              </a:ext>
-            </a:extLst>
-          </p:cNvPr>
-          <p:cNvSpPr txBox="1"/>
-          <p:nvPr/>
-        </p:nvSpPr>
-        <p:spPr>
-          <a:xfrm>
-            <a:off x="1424608" y="4509120"/>
-            <a:ext cx="3416320" cy="369332"/>
-          </a:xfrm>
-          <a:prstGeom prst="rect">
-            <a:avLst/>
-          </a:prstGeom>
-          <a:noFill/>
-        </p:spPr>
-        <p:txBody>
-          <a:bodyPr wrap="square" rtlCol="0"/>
-          <a:lstStyle/>
-          <a:p>
-            <a:pPr>
-              <a:defRPr sz="1300"/>
-            </a:pPr>
-            <a:r>
-              <a:rPr lang="ja-JP" altLang="en-US" sz="1300"/>
-              <a:t>Receive data directly from the sender</a:t>
-            </a:r>
-            <a:endParaRPr kumimoji="1" lang="ja-JP" altLang="en-US"/>
-          </a:p>
-        </p:txBody>
-      </p:sp>
       <p:pic>
         <p:nvPicPr>
-          <p:cNvPr id="17" name="図 16">
-            <a:extLst>
-              <a:ext uri="{FF2B5EF4-FFF2-40B4-BE49-F238E27FC236}">
-                <a16:creationId xmlns:a16="http://schemas.microsoft.com/office/drawing/2014/main" id="{0002F9A9-0841-4944-BE81-4D4ECB79E331}"/>
+          <p:cNvPr id="22" name="図 21">
+            <a:extLst>
+              <a:ext uri="{FF2B5EF4-FFF2-40B4-BE49-F238E27FC236}">
+                <a16:creationId xmlns:a16="http://schemas.microsoft.com/office/drawing/2014/main" id="{5A4B7F20-69F1-3348-8D07-5570EE3C8F8E}"/>
               </a:ext>
             </a:extLst>
           </p:cNvPr>
@@ -5998,21 +5888,57 @@
           </a:stretch>
         </p:blipFill>
         <p:spPr>
-          <a:xfrm>
-            <a:off x="6753200" y="2996952"/>
-            <a:ext cx="1008112" cy="1039290"/>
+          <a:xfrm flipH="1">
+            <a:off x="6537176" y="1268760"/>
+            <a:ext cx="1285376" cy="1558032"/>
           </a:xfrm>
           <a:prstGeom prst="rect">
             <a:avLst/>
           </a:prstGeom>
         </p:spPr>
       </p:pic>
+      <p:sp>
+        <p:nvSpPr>
+          <p:cNvPr id="24" name="テキスト ボックス 23">
+            <a:extLst>
+              <a:ext uri="{FF2B5EF4-FFF2-40B4-BE49-F238E27FC236}">
+                <a16:creationId xmlns:a16="http://schemas.microsoft.com/office/drawing/2014/main" id="{A67379DC-569C-FB44-B52D-B2D323CCE58A}"/>
+              </a:ext>
+            </a:extLst>
+          </p:cNvPr>
+          <p:cNvSpPr txBox="1"/>
+          <p:nvPr/>
+        </p:nvSpPr>
+        <p:spPr>
+          <a:xfrm>
+            <a:off x="5457057" y="4149080"/>
+            <a:ext cx="3384376" cy="369332"/>
+          </a:xfrm>
+          <a:prstGeom prst="rect">
+            <a:avLst/>
+          </a:prstGeom>
+          <a:noFill/>
+        </p:spPr>
+        <p:txBody>
+          <a:bodyPr wrap="square" rtlCol="0"/>
+          <a:lstStyle/>
+          <a:p>
+            <a:pPr>
+              <a:defRPr sz="1600"/>
+            </a:pPr>
+            <a:r>
+              <a:rPr kumimoji="1" lang="ja-JP" altLang="en-US" sz="1600"/>
+              <a:t>Receive it when the receiver is ready</a:t>
+            </a:r>
+          </a:p>
+        </p:txBody>
+      </p:sp>
       <p:pic>
         <p:nvPicPr>
-          <p:cNvPr id="22" name="図 21">
-            <a:extLst>
-              <a:ext uri="{FF2B5EF4-FFF2-40B4-BE49-F238E27FC236}">
-                <a16:creationId xmlns:a16="http://schemas.microsoft.com/office/drawing/2014/main" id="{5A4B7F20-69F1-3348-8D07-5570EE3C8F8E}"/>
+          <p:cNvPr id="25" name="図 24">
+            <a:extLst>
+              <a:ext uri="{FF2B5EF4-FFF2-40B4-BE49-F238E27FC236}">
+                <a16:creationId xmlns:a16="http://schemas.microsoft.com/office/drawing/2014/main" id="{9A8E7B6B-A07F-5246-A06C-7255B2B7D12D}"/>
               </a:ext>
             </a:extLst>
           </p:cNvPr>
@@ -6028,93 +5954,21 @@
           </a:stretch>
         </p:blipFill>
         <p:spPr>
-          <a:xfrm flipH="1">
-            <a:off x="6537176" y="1268760"/>
-            <a:ext cx="1285376" cy="1558032"/>
+          <a:xfrm>
+            <a:off x="6825208" y="4725144"/>
+            <a:ext cx="1440160" cy="1745648"/>
           </a:xfrm>
           <a:prstGeom prst="rect">
             <a:avLst/>
           </a:prstGeom>
         </p:spPr>
       </p:pic>
-      <p:sp>
-        <p:nvSpPr>
-          <p:cNvPr id="23" name="テキスト ボックス 22">
-            <a:extLst>
-              <a:ext uri="{FF2B5EF4-FFF2-40B4-BE49-F238E27FC236}">
-                <a16:creationId xmlns:a16="http://schemas.microsoft.com/office/drawing/2014/main" id="{5D046DA0-47F3-4B48-88DA-EEFFF875ED95}"/>
-              </a:ext>
-            </a:extLst>
-          </p:cNvPr>
-          <p:cNvSpPr txBox="1"/>
-          <p:nvPr/>
-        </p:nvSpPr>
-        <p:spPr>
-          <a:xfrm>
-            <a:off x="5745088" y="980728"/>
-            <a:ext cx="3416320" cy="369332"/>
-          </a:xfrm>
-          <a:prstGeom prst="rect">
-            <a:avLst/>
-          </a:prstGeom>
-          <a:noFill/>
-        </p:spPr>
-        <p:txBody>
-          <a:bodyPr wrap="square" rtlCol="0"/>
-          <a:lstStyle/>
-          <a:p>
-            <a:pPr>
-              <a:defRPr sz="1300"/>
-            </a:pPr>
-            <a:r>
-              <a:rPr kumimoji="1" lang="ja-JP" altLang="en-US" sz="1300"/>
-              <a:t>Place data in a predetermined location</a:t>
-            </a:r>
-          </a:p>
-        </p:txBody>
-      </p:sp>
-      <p:sp>
-        <p:nvSpPr>
-          <p:cNvPr id="24" name="テキスト ボックス 23">
-            <a:extLst>
-              <a:ext uri="{FF2B5EF4-FFF2-40B4-BE49-F238E27FC236}">
-                <a16:creationId xmlns:a16="http://schemas.microsoft.com/office/drawing/2014/main" id="{A67379DC-569C-FB44-B52D-B2D323CCE58A}"/>
-              </a:ext>
-            </a:extLst>
-          </p:cNvPr>
-          <p:cNvSpPr txBox="1"/>
-          <p:nvPr/>
-        </p:nvSpPr>
-        <p:spPr>
-          <a:xfrm>
-            <a:off x="5457056" y="4149080"/>
-            <a:ext cx="4108817" cy="369332"/>
-          </a:xfrm>
-          <a:prstGeom prst="rect">
-            <a:avLst/>
-          </a:prstGeom>
-          <a:noFill/>
-        </p:spPr>
-        <p:txBody>
-          <a:bodyPr wrap="square" rtlCol="0"/>
-          <a:lstStyle/>
-          <a:p>
-            <a:pPr>
-              <a:defRPr sz="1600"/>
-            </a:pPr>
-            <a:r>
-              <a:rPr kumimoji="1" lang="ja-JP" altLang="en-US" sz="1600"/>
-              <a:t>Receive it when the receiver is ready</a:t>
-            </a:r>
-          </a:p>
-        </p:txBody>
-      </p:sp>
       <p:pic>
         <p:nvPicPr>
-          <p:cNvPr id="25" name="図 24">
-            <a:extLst>
-              <a:ext uri="{FF2B5EF4-FFF2-40B4-BE49-F238E27FC236}">
-                <a16:creationId xmlns:a16="http://schemas.microsoft.com/office/drawing/2014/main" id="{9A8E7B6B-A07F-5246-A06C-7255B2B7D12D}"/>
+          <p:cNvPr id="26" name="図 25">
+            <a:extLst>
+              <a:ext uri="{FF2B5EF4-FFF2-40B4-BE49-F238E27FC236}">
+                <a16:creationId xmlns:a16="http://schemas.microsoft.com/office/drawing/2014/main" id="{BBFEE384-149A-AA4C-8BCE-03C8FE9FD664}"/>
               </a:ext>
             </a:extLst>
           </p:cNvPr>
@@ -6131,20 +5985,90 @@
         </p:blipFill>
         <p:spPr>
           <a:xfrm>
-            <a:off x="6825208" y="4725144"/>
-            <a:ext cx="1440160" cy="1745648"/>
+            <a:off x="7833320" y="3068960"/>
+            <a:ext cx="716133" cy="880492"/>
           </a:xfrm>
           <a:prstGeom prst="rect">
             <a:avLst/>
           </a:prstGeom>
         </p:spPr>
       </p:pic>
+      <p:sp>
+        <p:nvSpPr>
+          <p:cNvPr id="15" name="テキスト ボックス 14">
+            <a:extLst>
+              <a:ext uri="{FF2B5EF4-FFF2-40B4-BE49-F238E27FC236}">
+                <a16:creationId xmlns:a16="http://schemas.microsoft.com/office/drawing/2014/main" id="{C4FA0DAA-358B-9BF9-2A80-EC1FF998FB82}"/>
+              </a:ext>
+            </a:extLst>
+          </p:cNvPr>
+          <p:cNvSpPr txBox="1"/>
+          <p:nvPr/>
+        </p:nvSpPr>
+        <p:spPr>
+          <a:xfrm>
+            <a:off x="1722686" y="4624859"/>
+            <a:ext cx="3816424" cy="369332"/>
+          </a:xfrm>
+          <a:prstGeom prst="rect">
+            <a:avLst/>
+          </a:prstGeom>
+          <a:noFill/>
+        </p:spPr>
+        <p:txBody>
+          <a:bodyPr wrap="square">
+            <a:spAutoFit/>
+          </a:bodyPr>
+          <a:lstStyle/>
+          <a:p>
+            <a:r>
+              <a:rPr lang="ja-JP" altLang="en-US"/>
+              <a:t>Receive data directly from the sender</a:t>
+            </a:r>
+          </a:p>
+        </p:txBody>
+      </p:sp>
+      <p:sp>
+        <p:nvSpPr>
+          <p:cNvPr id="19" name="テキスト ボックス 18">
+            <a:extLst>
+              <a:ext uri="{FF2B5EF4-FFF2-40B4-BE49-F238E27FC236}">
+                <a16:creationId xmlns:a16="http://schemas.microsoft.com/office/drawing/2014/main" id="{0497DF87-A900-583B-B9E7-045FB1625DB7}"/>
+              </a:ext>
+            </a:extLst>
+          </p:cNvPr>
+          <p:cNvSpPr txBox="1"/>
+          <p:nvPr/>
+        </p:nvSpPr>
+        <p:spPr>
+          <a:xfrm>
+            <a:off x="5457056" y="843009"/>
+            <a:ext cx="3816424" cy="369332"/>
+          </a:xfrm>
+          <a:prstGeom prst="rect">
+            <a:avLst/>
+          </a:prstGeom>
+          <a:noFill/>
+        </p:spPr>
+        <p:txBody>
+          <a:bodyPr wrap="square">
+            <a:spAutoFit/>
+          </a:bodyPr>
+          <a:lstStyle/>
+          <a:p>
+            <a:r>
+              <a:rPr lang="ja-JP" altLang="en-US"/>
+              <a:t>Place data in a predetermined location</a:t>
+            </a:r>
+          </a:p>
+        </p:txBody>
+      </p:sp>
       <p:pic>
         <p:nvPicPr>
-          <p:cNvPr id="26" name="図 25">
-            <a:extLst>
-              <a:ext uri="{FF2B5EF4-FFF2-40B4-BE49-F238E27FC236}">
-                <a16:creationId xmlns:a16="http://schemas.microsoft.com/office/drawing/2014/main" id="{BBFEE384-149A-AA4C-8BCE-03C8FE9FD664}"/>
+          <p:cNvPr id="20" name="図 19" descr="白い封筒のイラスト（手紙）">
+            <a:extLst>
+              <a:ext uri="{FF2B5EF4-FFF2-40B4-BE49-F238E27FC236}">
+                <a16:creationId xmlns:a16="http://schemas.microsoft.com/office/drawing/2014/main" id="{F41D2D8C-EAA0-2305-452C-3EFEE709B809}"/>
               </a:ext>
             </a:extLst>
           </p:cNvPr>
@@ -6161,8 +6085,8 @@
         </p:blipFill>
         <p:spPr>
           <a:xfrm>
-            <a:off x="7833320" y="3068960"/>
-            <a:ext cx="716133" cy="880492"/>
+            <a:off x="6854547" y="2968317"/>
+            <a:ext cx="780780" cy="890089"/>
           </a:xfrm>
           <a:prstGeom prst="rect">
             <a:avLst/>
@@ -6201,44 +6125,6 @@
       </p:grpSpPr>
       <p:sp>
         <p:nvSpPr>
-          <p:cNvPr id="3" name="テキスト ボックス 2">
-            <a:extLst>
-              <a:ext uri="{FF2B5EF4-FFF2-40B4-BE49-F238E27FC236}">
-                <a16:creationId xmlns:a16="http://schemas.microsoft.com/office/drawing/2014/main" id="{DD22EA80-5E19-D744-9CD7-684C54056F60}"/>
-              </a:ext>
-            </a:extLst>
-          </p:cNvPr>
-          <p:cNvSpPr txBox="1"/>
-          <p:nvPr/>
-        </p:nvSpPr>
-        <p:spPr>
-          <a:xfrm>
-            <a:off x="436880" y="193040"/>
-            <a:ext cx="3262432" cy="400110"/>
-          </a:xfrm>
-          <a:prstGeom prst="rect">
-            <a:avLst/>
-          </a:prstGeom>
-          <a:noFill/>
-        </p:spPr>
-        <p:txBody>
-          <a:bodyPr wrap="square" rtlCol="0">
-            <a:normAutofit/>
-          </a:bodyPr>
-          <a:lstStyle/>
-          <a:p>
-            <a:pPr>
-              <a:defRPr/>
-            </a:pPr>
-            <a:r>
-              <a:rPr kumimoji="1" lang="ja-JP" altLang="en-US" sz="2000"/>
-              <a:t>Embarrassingly parallel workloads require almost no communication</a:t>
-            </a:r>
-          </a:p>
-        </p:txBody>
-      </p:sp>
-      <p:sp>
-        <p:nvSpPr>
           <p:cNvPr id="10" name="正方形/長方形 9">
             <a:extLst>
               <a:ext uri="{FF2B5EF4-FFF2-40B4-BE49-F238E27FC236}">
@@ -6251,7 +6137,7 @@
         </p:nvSpPr>
         <p:spPr>
           <a:xfrm>
-            <a:off x="1483360" y="741680"/>
+            <a:off x="1784648" y="1700808"/>
             <a:ext cx="1016000" cy="365760"/>
           </a:xfrm>
           <a:prstGeom prst="rect">
@@ -6275,8 +6161,8 @@
           </a:fontRef>
         </p:style>
         <p:txBody>
-          <a:bodyPr rtlCol="0" anchor="ctr" wrap="square">
-            <a:normAutofit/>
+          <a:bodyPr wrap="square" rtlCol="0" anchor="ctr">
+            <a:normAutofit fontScale="70000" lnSpcReduction="20000"/>
           </a:bodyPr>
           <a:lstStyle/>
           <a:p>
@@ -6304,7 +6190,7 @@
         </p:nvGrpSpPr>
         <p:grpSpPr>
           <a:xfrm>
-            <a:off x="243840" y="1676400"/>
+            <a:off x="545128" y="2635528"/>
             <a:ext cx="1066800" cy="3017520"/>
             <a:chOff x="243840" y="1676400"/>
             <a:chExt cx="1066800" cy="3017520"/>
@@ -6424,7 +6310,7 @@
         </p:nvGrpSpPr>
         <p:grpSpPr>
           <a:xfrm>
-            <a:off x="1463040" y="1676400"/>
+            <a:off x="1764328" y="2635528"/>
             <a:ext cx="1066800" cy="3017520"/>
             <a:chOff x="243840" y="1676400"/>
             <a:chExt cx="1066800" cy="3017520"/>
@@ -6544,7 +6430,7 @@
         </p:nvGrpSpPr>
         <p:grpSpPr>
           <a:xfrm>
-            <a:off x="2692400" y="1676400"/>
+            <a:off x="2993688" y="2635528"/>
             <a:ext cx="1066800" cy="3017520"/>
             <a:chOff x="243840" y="1676400"/>
             <a:chExt cx="1066800" cy="3017520"/>
@@ -6667,7 +6553,7 @@
         </p:nvCxnSpPr>
         <p:spPr>
           <a:xfrm flipH="1">
-            <a:off x="772160" y="1107440"/>
+            <a:off x="1073448" y="2066568"/>
             <a:ext cx="1219200" cy="589280"/>
           </a:xfrm>
           <a:prstGeom prst="straightConnector1">
@@ -6709,7 +6595,7 @@
         </p:nvCxnSpPr>
         <p:spPr>
           <a:xfrm>
-            <a:off x="1991360" y="1107440"/>
+            <a:off x="2292648" y="2066568"/>
             <a:ext cx="0" cy="589280"/>
           </a:xfrm>
           <a:prstGeom prst="straightConnector1">
@@ -6751,7 +6637,7 @@
         </p:nvCxnSpPr>
         <p:spPr>
           <a:xfrm>
-            <a:off x="1991360" y="1107440"/>
+            <a:off x="2292648" y="2066568"/>
             <a:ext cx="1234440" cy="568960"/>
           </a:xfrm>
           <a:prstGeom prst="straightConnector1">
@@ -6778,82 +6664,6 @@
       </p:cxnSp>
       <p:sp>
         <p:nvSpPr>
-          <p:cNvPr id="59" name="テキスト ボックス 58">
-            <a:extLst>
-              <a:ext uri="{FF2B5EF4-FFF2-40B4-BE49-F238E27FC236}">
-                <a16:creationId xmlns:a16="http://schemas.microsoft.com/office/drawing/2014/main" id="{75FEA925-4FAE-1E48-8B44-50F3927BF668}"/>
-              </a:ext>
-            </a:extLst>
-          </p:cNvPr>
-          <p:cNvSpPr txBox="1"/>
-          <p:nvPr/>
-        </p:nvSpPr>
-        <p:spPr>
-          <a:xfrm>
-            <a:off x="589280" y="4876800"/>
-            <a:ext cx="2954655" cy="369332"/>
-          </a:xfrm>
-          <a:prstGeom prst="rect">
-            <a:avLst/>
-          </a:prstGeom>
-          <a:noFill/>
-        </p:spPr>
-        <p:txBody>
-          <a:bodyPr wrap="square" rtlCol="0">
-            <a:normAutofit/>
-          </a:bodyPr>
-          <a:lstStyle/>
-          <a:p>
-            <a:pPr>
-              <a:defRPr/>
-            </a:pPr>
-            <a:r>
-              <a:rPr kumimoji="1" lang="ja-JP" altLang="en-US"/>
-              <a:t>No communication except during initialization</a:t>
-            </a:r>
-          </a:p>
-        </p:txBody>
-      </p:sp>
-      <p:sp>
-        <p:nvSpPr>
-          <p:cNvPr id="60" name="テキスト ボックス 59">
-            <a:extLst>
-              <a:ext uri="{FF2B5EF4-FFF2-40B4-BE49-F238E27FC236}">
-                <a16:creationId xmlns:a16="http://schemas.microsoft.com/office/drawing/2014/main" id="{3D86F1F8-6062-1A44-B3D0-187BD1E68DB9}"/>
-              </a:ext>
-            </a:extLst>
-          </p:cNvPr>
-          <p:cNvSpPr txBox="1"/>
-          <p:nvPr/>
-        </p:nvSpPr>
-        <p:spPr>
-          <a:xfrm>
-            <a:off x="5100320" y="182880"/>
-            <a:ext cx="3005951" cy="400110"/>
-          </a:xfrm>
-          <a:prstGeom prst="rect">
-            <a:avLst/>
-          </a:prstGeom>
-          <a:noFill/>
-        </p:spPr>
-        <p:txBody>
-          <a:bodyPr wrap="square" rtlCol="0">
-            <a:normAutofit/>
-          </a:bodyPr>
-          <a:lstStyle/>
-          <a:p>
-            <a:pPr>
-              <a:defRPr/>
-            </a:pPr>
-            <a:r>
-              <a:rPr kumimoji="1" lang="ja-JP" altLang="en-US" sz="2000"/>
-              <a:t>Embarrassingly parallel workloads do not require reliability</a:t>
-            </a:r>
-          </a:p>
-        </p:txBody>
-      </p:sp>
-      <p:sp>
-        <p:nvSpPr>
           <p:cNvPr id="61" name="正方形/長方形 60">
             <a:extLst>
               <a:ext uri="{FF2B5EF4-FFF2-40B4-BE49-F238E27FC236}">
@@ -6866,7 +6676,7 @@
         </p:nvSpPr>
         <p:spPr>
           <a:xfrm>
-            <a:off x="6167120" y="741680"/>
+            <a:off x="6468408" y="1700808"/>
             <a:ext cx="1016000" cy="365760"/>
           </a:xfrm>
           <a:prstGeom prst="rect">
@@ -6890,8 +6700,8 @@
           </a:fontRef>
         </p:style>
         <p:txBody>
-          <a:bodyPr rtlCol="0" anchor="ctr" wrap="square">
-            <a:normAutofit/>
+          <a:bodyPr wrap="square" rtlCol="0" anchor="ctr">
+            <a:normAutofit fontScale="70000" lnSpcReduction="20000"/>
           </a:bodyPr>
           <a:lstStyle/>
           <a:p>
@@ -6919,7 +6729,7 @@
         </p:nvGrpSpPr>
         <p:grpSpPr>
           <a:xfrm>
-            <a:off x="4927600" y="1676400"/>
+            <a:off x="5228888" y="2635528"/>
             <a:ext cx="1066800" cy="3017520"/>
             <a:chOff x="243840" y="1676400"/>
             <a:chExt cx="1066800" cy="3017520"/>
@@ -7039,7 +6849,7 @@
         </p:nvSpPr>
         <p:spPr>
           <a:xfrm>
-            <a:off x="6146800" y="1676400"/>
+            <a:off x="6448088" y="2635528"/>
             <a:ext cx="1066800" cy="914400"/>
           </a:xfrm>
           <a:prstGeom prst="rect">
@@ -7100,7 +6910,7 @@
         </p:nvSpPr>
         <p:spPr>
           <a:xfrm>
-            <a:off x="6146800" y="1696720"/>
+            <a:off x="6448088" y="2655848"/>
             <a:ext cx="1056640" cy="338554"/>
           </a:xfrm>
           <a:prstGeom prst="rect">
@@ -7138,7 +6948,7 @@
         </p:nvGrpSpPr>
         <p:grpSpPr>
           <a:xfrm>
-            <a:off x="7376160" y="1676400"/>
+            <a:off x="7677448" y="2635528"/>
             <a:ext cx="1066800" cy="3017520"/>
             <a:chOff x="243840" y="1676400"/>
             <a:chExt cx="1066800" cy="3017520"/>
@@ -7261,7 +7071,7 @@
         </p:nvCxnSpPr>
         <p:spPr>
           <a:xfrm flipH="1">
-            <a:off x="5455920" y="1107440"/>
+            <a:off x="5757208" y="2066568"/>
             <a:ext cx="1219200" cy="589280"/>
           </a:xfrm>
           <a:prstGeom prst="straightConnector1">
@@ -7303,7 +7113,7 @@
         </p:nvCxnSpPr>
         <p:spPr>
           <a:xfrm>
-            <a:off x="6675120" y="1107440"/>
+            <a:off x="6976408" y="2066568"/>
             <a:ext cx="0" cy="589280"/>
           </a:xfrm>
           <a:prstGeom prst="straightConnector1">
@@ -7345,7 +7155,7 @@
         </p:nvCxnSpPr>
         <p:spPr>
           <a:xfrm>
-            <a:off x="6675120" y="1107440"/>
+            <a:off x="6976408" y="2066568"/>
             <a:ext cx="1234440" cy="568960"/>
           </a:xfrm>
           <a:prstGeom prst="straightConnector1">
@@ -7384,7 +7194,7 @@
         </p:nvSpPr>
         <p:spPr>
           <a:xfrm>
-            <a:off x="6299200" y="2225040"/>
+            <a:off x="6600488" y="3184168"/>
             <a:ext cx="782320" cy="782320"/>
           </a:xfrm>
           <a:prstGeom prst="irregularSeal2">
@@ -7438,7 +7248,7 @@
         </p:nvSpPr>
         <p:spPr>
           <a:xfrm>
-            <a:off x="6004560" y="2926080"/>
+            <a:off x="6305848" y="3885208"/>
             <a:ext cx="1338828" cy="369332"/>
           </a:xfrm>
           <a:prstGeom prst="rect">
@@ -7462,10 +7272,10 @@
       </p:sp>
       <p:sp>
         <p:nvSpPr>
-          <p:cNvPr id="76" name="テキスト ボックス 75">
-            <a:extLst>
-              <a:ext uri="{FF2B5EF4-FFF2-40B4-BE49-F238E27FC236}">
-                <a16:creationId xmlns:a16="http://schemas.microsoft.com/office/drawing/2014/main" id="{2B711898-29E3-8B48-9055-8A9C6D022E92}"/>
+          <p:cNvPr id="4" name="テキスト ボックス 3">
+            <a:extLst>
+              <a:ext uri="{FF2B5EF4-FFF2-40B4-BE49-F238E27FC236}">
+                <a16:creationId xmlns:a16="http://schemas.microsoft.com/office/drawing/2014/main" id="{56F337F9-6E5C-B2E8-B028-FA8A079073FB}"/>
               </a:ext>
             </a:extLst>
           </p:cNvPr>
@@ -7474,8 +7284,8 @@
         </p:nvSpPr>
         <p:spPr>
           <a:xfrm>
-            <a:off x="4998720" y="4886960"/>
-            <a:ext cx="3647152" cy="369332"/>
+            <a:off x="301288" y="5935742"/>
+            <a:ext cx="4590492" cy="369332"/>
           </a:xfrm>
           <a:prstGeom prst="rect">
             <a:avLst/>
@@ -7483,17 +7293,119 @@
           <a:noFill/>
         </p:spPr>
         <p:txBody>
-          <a:bodyPr wrap="square" rtlCol="0">
-            <a:normAutofit/>
+          <a:bodyPr wrap="square">
+            <a:spAutoFit/>
           </a:bodyPr>
           <a:lstStyle/>
           <a:p>
-            <a:pPr>
-              <a:defRPr/>
-            </a:pPr>
             <a:r>
-              <a:rPr kumimoji="1" lang="ja-JP" altLang="en-US"/>
+              <a:rPr lang="ja-JP" altLang="en-US"/>
+              <a:t>No communication except during initialization</a:t>
+            </a:r>
+          </a:p>
+        </p:txBody>
+      </p:sp>
+      <p:sp>
+        <p:nvSpPr>
+          <p:cNvPr id="6" name="テキスト ボックス 5">
+            <a:extLst>
+              <a:ext uri="{FF2B5EF4-FFF2-40B4-BE49-F238E27FC236}">
+                <a16:creationId xmlns:a16="http://schemas.microsoft.com/office/drawing/2014/main" id="{5E6549F1-7C5A-7FEC-E7B0-99A4F88329C2}"/>
+              </a:ext>
+            </a:extLst>
+          </p:cNvPr>
+          <p:cNvSpPr txBox="1"/>
+          <p:nvPr/>
+        </p:nvSpPr>
+        <p:spPr>
+          <a:xfrm>
+            <a:off x="5155197" y="5956062"/>
+            <a:ext cx="4419571" cy="369332"/>
+          </a:xfrm>
+          <a:prstGeom prst="rect">
+            <a:avLst/>
+          </a:prstGeom>
+          <a:noFill/>
+        </p:spPr>
+        <p:txBody>
+          <a:bodyPr wrap="square">
+            <a:spAutoFit/>
+          </a:bodyPr>
+          <a:lstStyle/>
+          <a:p>
+            <a:r>
+              <a:rPr lang="ja-JP" altLang="en-US"/>
               <a:t>Only the failed calculation needs to be rerun</a:t>
+            </a:r>
+          </a:p>
+        </p:txBody>
+      </p:sp>
+      <p:sp>
+        <p:nvSpPr>
+          <p:cNvPr id="8" name="テキスト ボックス 7">
+            <a:extLst>
+              <a:ext uri="{FF2B5EF4-FFF2-40B4-BE49-F238E27FC236}">
+                <a16:creationId xmlns:a16="http://schemas.microsoft.com/office/drawing/2014/main" id="{27585C96-CB3B-F170-FB65-0B5247B6A041}"/>
+              </a:ext>
+            </a:extLst>
+          </p:cNvPr>
+          <p:cNvSpPr txBox="1"/>
+          <p:nvPr/>
+        </p:nvSpPr>
+        <p:spPr>
+          <a:xfrm>
+            <a:off x="545128" y="715923"/>
+            <a:ext cx="3476659" cy="646331"/>
+          </a:xfrm>
+          <a:prstGeom prst="rect">
+            <a:avLst/>
+          </a:prstGeom>
+          <a:noFill/>
+        </p:spPr>
+        <p:txBody>
+          <a:bodyPr wrap="square">
+            <a:spAutoFit/>
+          </a:bodyPr>
+          <a:lstStyle/>
+          <a:p>
+            <a:r>
+              <a:rPr lang="ja-JP" altLang="en-US"/>
+              <a:t>Embarrassingly parallel workloads require almost no communication</a:t>
+            </a:r>
+          </a:p>
+        </p:txBody>
+      </p:sp>
+      <p:sp>
+        <p:nvSpPr>
+          <p:cNvPr id="11" name="テキスト ボックス 10">
+            <a:extLst>
+              <a:ext uri="{FF2B5EF4-FFF2-40B4-BE49-F238E27FC236}">
+                <a16:creationId xmlns:a16="http://schemas.microsoft.com/office/drawing/2014/main" id="{6D87DEED-1982-DF02-BAE2-E45EE3455B95}"/>
+              </a:ext>
+            </a:extLst>
+          </p:cNvPr>
+          <p:cNvSpPr txBox="1"/>
+          <p:nvPr/>
+        </p:nvSpPr>
+        <p:spPr>
+          <a:xfrm>
+            <a:off x="5285884" y="715923"/>
+            <a:ext cx="3378755" cy="646331"/>
+          </a:xfrm>
+          <a:prstGeom prst="rect">
+            <a:avLst/>
+          </a:prstGeom>
+          <a:noFill/>
+        </p:spPr>
+        <p:txBody>
+          <a:bodyPr wrap="square">
+            <a:spAutoFit/>
+          </a:bodyPr>
+          <a:lstStyle/>
+          <a:p>
+            <a:r>
+              <a:rPr lang="ja-JP" altLang="en-US"/>
+              <a:t>Embarrassingly parallel workloads do not require reliability</a:t>
             </a:r>
           </a:p>
         </p:txBody>
@@ -9883,11 +9795,6 @@
                 </a:rPr>
                 <a:t>Process 1</a:t>
               </a:r>
-              <a:endParaRPr kumimoji="1" lang="ja-JP" altLang="en-US" sz="1200">
-                <a:solidFill>
-                  <a:schemeClr val="tx1"/>
-                </a:solidFill>
-              </a:endParaRPr>
             </a:p>
           </p:txBody>
         </p:sp>
@@ -9954,11 +9861,6 @@
                 </a:rPr>
                 <a:t>Process 2</a:t>
               </a:r>
-              <a:endParaRPr kumimoji="1" lang="ja-JP" altLang="en-US" sz="1200">
-                <a:solidFill>
-                  <a:schemeClr val="tx1"/>
-                </a:solidFill>
-              </a:endParaRPr>
             </a:p>
           </p:txBody>
         </p:sp>
@@ -10025,11 +9927,6 @@
                 </a:rPr>
                 <a:t>Process 3</a:t>
               </a:r>
-              <a:endParaRPr kumimoji="1" lang="ja-JP" altLang="en-US" sz="1200">
-                <a:solidFill>
-                  <a:schemeClr val="tx1"/>
-                </a:solidFill>
-              </a:endParaRPr>
             </a:p>
           </p:txBody>
         </p:sp>
@@ -10096,11 +9993,6 @@
                 </a:rPr>
                 <a:t>Process 4</a:t>
               </a:r>
-              <a:endParaRPr kumimoji="1" lang="ja-JP" altLang="en-US" sz="1200">
-                <a:solidFill>
-                  <a:schemeClr val="tx1"/>
-                </a:solidFill>
-              </a:endParaRPr>
             </a:p>
           </p:txBody>
         </p:sp>
@@ -10188,11 +10080,6 @@
                 </a:rPr>
                 <a:t>Process 1</a:t>
               </a:r>
-              <a:endParaRPr kumimoji="1" lang="ja-JP" altLang="en-US" sz="1200">
-                <a:solidFill>
-                  <a:schemeClr val="tx1"/>
-                </a:solidFill>
-              </a:endParaRPr>
             </a:p>
           </p:txBody>
         </p:sp>
@@ -10259,11 +10146,6 @@
                 </a:rPr>
                 <a:t>Process 2</a:t>
               </a:r>
-              <a:endParaRPr kumimoji="1" lang="ja-JP" altLang="en-US" sz="1200">
-                <a:solidFill>
-                  <a:schemeClr val="tx1"/>
-                </a:solidFill>
-              </a:endParaRPr>
             </a:p>
           </p:txBody>
         </p:sp>
@@ -10330,11 +10212,6 @@
                 </a:rPr>
                 <a:t>Process 3</a:t>
               </a:r>
-              <a:endParaRPr kumimoji="1" lang="ja-JP" altLang="en-US" sz="1200">
-                <a:solidFill>
-                  <a:schemeClr val="tx1"/>
-                </a:solidFill>
-              </a:endParaRPr>
             </a:p>
           </p:txBody>
         </p:sp>
@@ -10401,11 +10278,6 @@
                 </a:rPr>
                 <a:t>Process 4</a:t>
               </a:r>
-              <a:endParaRPr kumimoji="1" lang="ja-JP" altLang="en-US" sz="1200">
-                <a:solidFill>
-                  <a:schemeClr val="tx1"/>
-                </a:solidFill>
-              </a:endParaRPr>
             </a:p>
           </p:txBody>
         </p:sp>
@@ -10493,11 +10365,6 @@
                 </a:rPr>
                 <a:t>Process 1</a:t>
               </a:r>
-              <a:endParaRPr kumimoji="1" lang="ja-JP" altLang="en-US" sz="1200">
-                <a:solidFill>
-                  <a:schemeClr val="tx1"/>
-                </a:solidFill>
-              </a:endParaRPr>
             </a:p>
           </p:txBody>
         </p:sp>
@@ -10564,11 +10431,6 @@
                 </a:rPr>
                 <a:t>Process 2</a:t>
               </a:r>
-              <a:endParaRPr kumimoji="1" lang="ja-JP" altLang="en-US" sz="1200">
-                <a:solidFill>
-                  <a:schemeClr val="tx1"/>
-                </a:solidFill>
-              </a:endParaRPr>
             </a:p>
           </p:txBody>
         </p:sp>
@@ -10635,11 +10497,6 @@
                 </a:rPr>
                 <a:t>Process 3</a:t>
               </a:r>
-              <a:endParaRPr kumimoji="1" lang="ja-JP" altLang="en-US" sz="1200">
-                <a:solidFill>
-                  <a:schemeClr val="tx1"/>
-                </a:solidFill>
-              </a:endParaRPr>
             </a:p>
           </p:txBody>
         </p:sp>
@@ -10706,11 +10563,6 @@
                 </a:rPr>
                 <a:t>Process 4</a:t>
               </a:r>
-              <a:endParaRPr kumimoji="1" lang="ja-JP" altLang="en-US" sz="1200">
-                <a:solidFill>
-                  <a:schemeClr val="tx1"/>
-                </a:solidFill>
-              </a:endParaRPr>
             </a:p>
           </p:txBody>
         </p:sp>
@@ -11125,7 +10977,6 @@
               <a:rPr kumimoji="1" lang="ja-JP" altLang="en-US"/>
               <a:t>Non-trivial parallelism</a:t>
             </a:r>
-            <a:endParaRPr kumimoji="1" lang="ja-JP" altLang="en-US"/>
           </a:p>
           <a:p>
             <a:pPr>
@@ -11135,7 +10986,6 @@
               <a:rPr kumimoji="1" lang="ja-JP" altLang="en-US"/>
               <a:t>(global communication)</a:t>
             </a:r>
-            <a:endParaRPr kumimoji="1" lang="ja-JP" altLang="en-US"/>
           </a:p>
         </p:txBody>
       </p:sp>
@@ -11174,7 +11024,6 @@
               <a:rPr kumimoji="1" lang="ja-JP" altLang="en-US"/>
               <a:t>Non-trivial parallelism</a:t>
             </a:r>
-            <a:endParaRPr kumimoji="1" lang="ja-JP" altLang="en-US"/>
           </a:p>
           <a:p>
             <a:pPr>
@@ -11184,7 +11033,6 @@
               <a:rPr kumimoji="1" lang="ja-JP" altLang="en-US"/>
               <a:t>(local communication)</a:t>
             </a:r>
-            <a:endParaRPr kumimoji="1" lang="ja-JP" altLang="en-US"/>
           </a:p>
         </p:txBody>
       </p:sp>
@@ -11202,8 +11050,8 @@
         </p:nvSpPr>
         <p:spPr>
           <a:xfrm rot="16200000">
-            <a:off x="-305921" y="1859281"/>
-            <a:ext cx="1225015" cy="369332"/>
+            <a:off x="-65094" y="1786756"/>
+            <a:ext cx="751456" cy="369332"/>
           </a:xfrm>
           <a:prstGeom prst="rect">
             <a:avLst/>
@@ -11211,7 +11059,7 @@
           <a:noFill/>
         </p:spPr>
         <p:txBody>
-          <a:bodyPr wrap="none" rtlCol="0">
+          <a:bodyPr wrap="square" rtlCol="0">
             <a:spAutoFit/>
           </a:bodyPr>
           <a:lstStyle/>
@@ -11241,7 +11089,7 @@
         <p:spPr>
           <a:xfrm>
             <a:off x="1219200" y="3200400"/>
-            <a:ext cx="2957861" cy="369332"/>
+            <a:ext cx="3429000" cy="369332"/>
           </a:xfrm>
           <a:prstGeom prst="rect">
             <a:avLst/>
@@ -11348,11 +11196,6 @@
                 </a:rPr>
                 <a:t>Process 1</a:t>
               </a:r>
-              <a:endParaRPr kumimoji="1" lang="ja-JP" altLang="en-US" sz="1200">
-                <a:solidFill>
-                  <a:schemeClr val="tx1"/>
-                </a:solidFill>
-              </a:endParaRPr>
             </a:p>
           </p:txBody>
         </p:sp>
@@ -11419,11 +11262,6 @@
                 </a:rPr>
                 <a:t>Process 2</a:t>
               </a:r>
-              <a:endParaRPr kumimoji="1" lang="ja-JP" altLang="en-US" sz="1200">
-                <a:solidFill>
-                  <a:schemeClr val="tx1"/>
-                </a:solidFill>
-              </a:endParaRPr>
             </a:p>
           </p:txBody>
         </p:sp>
@@ -11511,11 +11349,6 @@
                 </a:rPr>
                 <a:t>Process 3</a:t>
               </a:r>
-              <a:endParaRPr kumimoji="1" lang="ja-JP" altLang="en-US" sz="1200">
-                <a:solidFill>
-                  <a:schemeClr val="tx1"/>
-                </a:solidFill>
-              </a:endParaRPr>
             </a:p>
           </p:txBody>
         </p:sp>
@@ -11582,11 +11415,6 @@
                 </a:rPr>
                 <a:t>Process 4</a:t>
               </a:r>
-              <a:endParaRPr kumimoji="1" lang="ja-JP" altLang="en-US" sz="1200">
-                <a:solidFill>
-                  <a:schemeClr val="tx1"/>
-                </a:solidFill>
-              </a:endParaRPr>
             </a:p>
           </p:txBody>
         </p:sp>
@@ -11836,8 +11664,8 @@
         </p:nvSpPr>
         <p:spPr>
           <a:xfrm rot="16200000">
-            <a:off x="5404000" y="1767842"/>
-            <a:ext cx="1225015" cy="369332"/>
+            <a:off x="5723617" y="1786181"/>
+            <a:ext cx="751455" cy="369332"/>
           </a:xfrm>
           <a:prstGeom prst="rect">
             <a:avLst/>
@@ -11845,7 +11673,7 @@
           <a:noFill/>
         </p:spPr>
         <p:txBody>
-          <a:bodyPr wrap="none" rtlCol="0">
+          <a:bodyPr wrap="square" rtlCol="0">
             <a:spAutoFit/>
           </a:bodyPr>
           <a:lstStyle/>
@@ -11854,7 +11682,7 @@
               <a:defRPr/>
             </a:pPr>
             <a:r>
-              <a:rPr kumimoji="1" lang="en-US" altLang="ja-JP"/>
+              <a:rPr kumimoji="1" lang="en-US" altLang="ja-JP" dirty="0"/>
               <a:t>1 step</a:t>
             </a:r>
           </a:p>
@@ -11919,8 +11747,8 @@
         </p:nvSpPr>
         <p:spPr>
           <a:xfrm>
-            <a:off x="6969760" y="3200400"/>
-            <a:ext cx="1569660" cy="369332"/>
+            <a:off x="6429784" y="3200400"/>
+            <a:ext cx="3010351" cy="369332"/>
           </a:xfrm>
           <a:prstGeom prst="rect">
             <a:avLst/>
@@ -13763,7 +13591,7 @@
         <p:spPr>
           <a:xfrm>
             <a:off x="1163781" y="110836"/>
-            <a:ext cx="2076209" cy="1077218"/>
+            <a:ext cx="3141147" cy="1077218"/>
           </a:xfrm>
           <a:prstGeom prst="rect">
             <a:avLst/>
@@ -13783,7 +13611,7 @@
               <a:rPr kumimoji="1" lang="ja-JP" altLang="en-US" sz="3200"/>
               <a:t>Uniform heating</a:t>
             </a:r>
-            <a:endParaRPr kumimoji="1" lang="en-US" altLang="ja-JP" sz="3200"/>
+            <a:endParaRPr kumimoji="1" lang="en-US" altLang="ja-JP" sz="3200" dirty="0"/>
           </a:p>
           <a:p>
             <a:pPr>
@@ -13793,7 +13621,7 @@
               <a:rPr kumimoji="1" lang="ja-JP" altLang="en-US" sz="3200"/>
               <a:t>(fixed boundary)</a:t>
             </a:r>
-            <a:endParaRPr kumimoji="1" lang="en-US" altLang="ja-JP" sz="3200"/>
+            <a:endParaRPr kumimoji="1" lang="en-US" altLang="ja-JP" sz="3200" dirty="0"/>
           </a:p>
         </p:txBody>
       </p:sp>
@@ -13811,8 +13639,8 @@
         </p:nvSpPr>
         <p:spPr>
           <a:xfrm>
-            <a:off x="6179126" y="124690"/>
-            <a:ext cx="2076209" cy="1077218"/>
+            <a:off x="5496624" y="70339"/>
+            <a:ext cx="3662375" cy="1077218"/>
           </a:xfrm>
           <a:prstGeom prst="rect">
             <a:avLst/>
@@ -13832,7 +13660,7 @@
               <a:rPr kumimoji="1" lang="ja-JP" altLang="en-US" sz="3200"/>
               <a:t>Fixed temperature</a:t>
             </a:r>
-            <a:endParaRPr kumimoji="1" lang="en-US" altLang="ja-JP" sz="3200"/>
+            <a:endParaRPr kumimoji="1" lang="en-US" altLang="ja-JP" sz="3200" dirty="0"/>
           </a:p>
           <a:p>
             <a:pPr>
@@ -13842,16 +13670,58 @@
               <a:rPr kumimoji="1" lang="ja-JP" altLang="en-US" sz="3200"/>
               <a:t>(periodic boundary)</a:t>
             </a:r>
-            <a:endParaRPr kumimoji="1" lang="en-US" altLang="ja-JP" sz="3200"/>
-          </a:p>
-        </p:txBody>
-      </p:sp>
-      <p:sp>
-        <p:nvSpPr>
-          <p:cNvPr id="21" name="テキスト ボックス 20">
-            <a:extLst>
-              <a:ext uri="{FF2B5EF4-FFF2-40B4-BE49-F238E27FC236}">
-                <a16:creationId xmlns:a16="http://schemas.microsoft.com/office/drawing/2014/main" id="{4BD4E71E-D458-E04A-8E69-2CBBB64C3CBA}"/>
+            <a:endParaRPr kumimoji="1" lang="en-US" altLang="ja-JP" sz="3200" dirty="0"/>
+          </a:p>
+        </p:txBody>
+      </p:sp>
+      <p:cxnSp>
+        <p:nvCxnSpPr>
+          <p:cNvPr id="23" name="直線矢印コネクタ 22">
+            <a:extLst>
+              <a:ext uri="{FF2B5EF4-FFF2-40B4-BE49-F238E27FC236}">
+                <a16:creationId xmlns:a16="http://schemas.microsoft.com/office/drawing/2014/main" id="{2B866937-231A-2E43-8596-782D00B7436D}"/>
+              </a:ext>
+            </a:extLst>
+          </p:cNvPr>
+          <p:cNvCxnSpPr/>
+          <p:nvPr/>
+        </p:nvCxnSpPr>
+        <p:spPr>
+          <a:xfrm>
+            <a:off x="152400" y="6502523"/>
+            <a:ext cx="4253346" cy="0"/>
+          </a:xfrm>
+          <a:prstGeom prst="straightConnector1">
+            <a:avLst/>
+          </a:prstGeom>
+          <a:ln>
+            <a:solidFill>
+              <a:schemeClr val="tx1"/>
+            </a:solidFill>
+            <a:tailEnd type="triangle"/>
+          </a:ln>
+        </p:spPr>
+        <p:style>
+          <a:lnRef idx="1">
+            <a:schemeClr val="accent1"/>
+          </a:lnRef>
+          <a:fillRef idx="0">
+            <a:schemeClr val="accent1"/>
+          </a:fillRef>
+          <a:effectRef idx="0">
+            <a:schemeClr val="accent1"/>
+          </a:effectRef>
+          <a:fontRef idx="minor">
+            <a:schemeClr val="tx1"/>
+          </a:fontRef>
+        </p:style>
+      </p:cxnSp>
+      <p:sp>
+        <p:nvSpPr>
+          <p:cNvPr id="24" name="テキスト ボックス 23">
+            <a:extLst>
+              <a:ext uri="{FF2B5EF4-FFF2-40B4-BE49-F238E27FC236}">
+                <a16:creationId xmlns:a16="http://schemas.microsoft.com/office/drawing/2014/main" id="{2CC81159-5BC6-AC45-87CE-E653C209EB53}"/>
               </a:ext>
             </a:extLst>
           </p:cNvPr>
@@ -13860,8 +13730,8 @@
         </p:nvSpPr>
         <p:spPr>
           <a:xfrm>
-            <a:off x="831273" y="3574473"/>
-            <a:ext cx="3007555" cy="646331"/>
+            <a:off x="9116293" y="5671249"/>
+            <a:ext cx="373212" cy="369332"/>
           </a:xfrm>
           <a:prstGeom prst="rect">
             <a:avLst/>
@@ -13878,139 +13748,10 @@
               <a:defRPr/>
             </a:pPr>
             <a:r>
-              <a:rPr kumimoji="1" lang="ja-JP" altLang="en-US"/>
-              <a:t>Heat the entire rod</a:t>
+              <a:rPr kumimoji="1" lang="en-US" altLang="ja-JP" dirty="0"/>
+              <a:t>x</a:t>
             </a:r>
-            <a:endParaRPr kumimoji="1" lang="en-US" altLang="ja-JP"/>
-          </a:p>
-          <a:p>
-            <a:pPr>
-              <a:defRPr/>
-            </a:pPr>
-            <a:r>
-              <a:rPr kumimoji="1" lang="ja-JP" altLang="en-US"/>
-              <a:t>Fix both ends at the same temperature</a:t>
-            </a:r>
-            <a:endParaRPr kumimoji="1" lang="en-US" altLang="ja-JP"/>
-          </a:p>
-        </p:txBody>
-      </p:sp>
-      <p:sp>
-        <p:nvSpPr>
-          <p:cNvPr id="22" name="テキスト ボックス 21">
-            <a:extLst>
-              <a:ext uri="{FF2B5EF4-FFF2-40B4-BE49-F238E27FC236}">
-                <a16:creationId xmlns:a16="http://schemas.microsoft.com/office/drawing/2014/main" id="{E62CD793-C1F0-8143-9804-B340F4A44522}"/>
-              </a:ext>
-            </a:extLst>
-          </p:cNvPr>
-          <p:cNvSpPr txBox="1"/>
-          <p:nvPr/>
-        </p:nvSpPr>
-        <p:spPr>
-          <a:xfrm>
-            <a:off x="4987637" y="3560619"/>
-            <a:ext cx="4801314" cy="369332"/>
-          </a:xfrm>
-          <a:prstGeom prst="rect">
-            <a:avLst/>
-          </a:prstGeom>
-          <a:noFill/>
-        </p:spPr>
-        <p:txBody>
-          <a:bodyPr wrap="square" rtlCol="0">
-            <a:normAutofit/>
-          </a:bodyPr>
-          <a:lstStyle/>
-          <a:p>
-            <a:pPr>
-              <a:defRPr/>
-            </a:pPr>
-            <a:r>
-              <a:rPr kumimoji="1" lang="ja-JP" altLang="en-US"/>
-              <a:t>Fix the left side of a metal ring at high temperature and the right side at low temperature</a:t>
-            </a:r>
-            <a:endParaRPr kumimoji="1" lang="en-US" altLang="ja-JP"/>
-          </a:p>
-        </p:txBody>
-      </p:sp>
-      <p:cxnSp>
-        <p:nvCxnSpPr>
-          <p:cNvPr id="23" name="直線矢印コネクタ 22">
-            <a:extLst>
-              <a:ext uri="{FF2B5EF4-FFF2-40B4-BE49-F238E27FC236}">
-                <a16:creationId xmlns:a16="http://schemas.microsoft.com/office/drawing/2014/main" id="{2B866937-231A-2E43-8596-782D00B7436D}"/>
-              </a:ext>
-            </a:extLst>
-          </p:cNvPr>
-          <p:cNvCxnSpPr/>
-          <p:nvPr/>
-        </p:nvCxnSpPr>
-        <p:spPr>
-          <a:xfrm>
-            <a:off x="152400" y="6502523"/>
-            <a:ext cx="4253346" cy="0"/>
-          </a:xfrm>
-          <a:prstGeom prst="straightConnector1">
-            <a:avLst/>
-          </a:prstGeom>
-          <a:ln>
-            <a:solidFill>
-              <a:schemeClr val="tx1"/>
-            </a:solidFill>
-            <a:tailEnd type="triangle"/>
-          </a:ln>
-        </p:spPr>
-        <p:style>
-          <a:lnRef idx="1">
-            <a:schemeClr val="accent1"/>
-          </a:lnRef>
-          <a:fillRef idx="0">
-            <a:schemeClr val="accent1"/>
-          </a:fillRef>
-          <a:effectRef idx="0">
-            <a:schemeClr val="accent1"/>
-          </a:effectRef>
-          <a:fontRef idx="minor">
-            <a:schemeClr val="tx1"/>
-          </a:fontRef>
-        </p:style>
-      </p:cxnSp>
-      <p:sp>
-        <p:nvSpPr>
-          <p:cNvPr id="24" name="テキスト ボックス 23">
-            <a:extLst>
-              <a:ext uri="{FF2B5EF4-FFF2-40B4-BE49-F238E27FC236}">
-                <a16:creationId xmlns:a16="http://schemas.microsoft.com/office/drawing/2014/main" id="{2CC81159-5BC6-AC45-87CE-E653C209EB53}"/>
-              </a:ext>
-            </a:extLst>
-          </p:cNvPr>
-          <p:cNvSpPr txBox="1"/>
-          <p:nvPr/>
-        </p:nvSpPr>
-        <p:spPr>
-          <a:xfrm>
-            <a:off x="9116292" y="5671249"/>
-            <a:ext cx="646331" cy="369332"/>
-          </a:xfrm>
-          <a:prstGeom prst="rect">
-            <a:avLst/>
-          </a:prstGeom>
-          <a:noFill/>
-        </p:spPr>
-        <p:txBody>
-          <a:bodyPr wrap="square" rtlCol="0">
-            <a:normAutofit/>
-          </a:bodyPr>
-          <a:lstStyle/>
-          <a:p>
-            <a:pPr>
-              <a:defRPr/>
-            </a:pPr>
-            <a:r>
-              <a:rPr kumimoji="1" lang="ja-JP" altLang="en-US"/>
-              <a:t>Coordinate</a:t>
-            </a:r>
+            <a:endParaRPr kumimoji="1" lang="ja-JP" altLang="en-US"/>
           </a:p>
         </p:txBody>
       </p:sp>
@@ -14072,8 +13813,8 @@
         </p:nvSpPr>
         <p:spPr>
           <a:xfrm>
-            <a:off x="0" y="4419600"/>
-            <a:ext cx="646331" cy="369332"/>
+            <a:off x="177216" y="4428196"/>
+            <a:ext cx="332509" cy="369332"/>
           </a:xfrm>
           <a:prstGeom prst="rect">
             <a:avLst/>
@@ -14091,7 +13832,7 @@
             </a:pPr>
             <a:r>
               <a:rPr lang="ja-JP" altLang="en-US"/>
-              <a:t>Temperature</a:t>
+              <a:t>T</a:t>
             </a:r>
             <a:endParaRPr kumimoji="1" lang="ja-JP" altLang="en-US"/>
           </a:p>
@@ -14289,8 +14030,8 @@
         </p:nvSpPr>
         <p:spPr>
           <a:xfrm>
-            <a:off x="5250873" y="4336473"/>
-            <a:ext cx="646331" cy="369332"/>
+            <a:off x="5398726" y="4345770"/>
+            <a:ext cx="346362" cy="369332"/>
           </a:xfrm>
           <a:prstGeom prst="rect">
             <a:avLst/>
@@ -14307,8 +14048,8 @@
               <a:defRPr/>
             </a:pPr>
             <a:r>
-              <a:rPr lang="ja-JP" altLang="en-US"/>
-              <a:t>Temperature</a:t>
+              <a:rPr kumimoji="1" lang="en-US" altLang="ja-JP" dirty="0"/>
+              <a:t>T</a:t>
             </a:r>
             <a:endParaRPr kumimoji="1" lang="ja-JP" altLang="en-US"/>
           </a:p>
@@ -14453,8 +14194,8 @@
         </p:nvSpPr>
         <p:spPr>
           <a:xfrm>
-            <a:off x="3740728" y="4932218"/>
-            <a:ext cx="1620957" cy="523220"/>
+            <a:off x="3368828" y="4932218"/>
+            <a:ext cx="1992858" cy="523220"/>
           </a:xfrm>
           <a:prstGeom prst="rect">
             <a:avLst/>
@@ -14481,6 +14222,82 @@
             <a:r>
               <a:rPr kumimoji="1" lang="ja-JP" altLang="en-US" sz="2800"/>
               <a:t>Steady state</a:t>
+            </a:r>
+          </a:p>
+        </p:txBody>
+      </p:sp>
+      <p:sp>
+        <p:nvSpPr>
+          <p:cNvPr id="3" name="テキスト ボックス 2">
+            <a:extLst>
+              <a:ext uri="{FF2B5EF4-FFF2-40B4-BE49-F238E27FC236}">
+                <a16:creationId xmlns:a16="http://schemas.microsoft.com/office/drawing/2014/main" id="{EFC555B2-7D1E-0C95-9BF8-36CB66D0FCA5}"/>
+              </a:ext>
+            </a:extLst>
+          </p:cNvPr>
+          <p:cNvSpPr txBox="1"/>
+          <p:nvPr/>
+        </p:nvSpPr>
+        <p:spPr>
+          <a:xfrm>
+            <a:off x="239325" y="3571921"/>
+            <a:ext cx="3921587" cy="646331"/>
+          </a:xfrm>
+          <a:prstGeom prst="rect">
+            <a:avLst/>
+          </a:prstGeom>
+          <a:noFill/>
+        </p:spPr>
+        <p:txBody>
+          <a:bodyPr wrap="square">
+            <a:spAutoFit/>
+          </a:bodyPr>
+          <a:lstStyle/>
+          <a:p>
+            <a:r>
+              <a:rPr lang="ja-JP" altLang="en-US"/>
+              <a:t>Heat the entire rod</a:t>
+            </a:r>
+          </a:p>
+          <a:p>
+            <a:r>
+              <a:rPr lang="ja-JP" altLang="en-US"/>
+              <a:t>Fix both ends at the same temperature</a:t>
+            </a:r>
+          </a:p>
+        </p:txBody>
+      </p:sp>
+      <p:sp>
+        <p:nvSpPr>
+          <p:cNvPr id="10" name="テキスト ボックス 9">
+            <a:extLst>
+              <a:ext uri="{FF2B5EF4-FFF2-40B4-BE49-F238E27FC236}">
+                <a16:creationId xmlns:a16="http://schemas.microsoft.com/office/drawing/2014/main" id="{B26EC9ED-88D2-E212-6BAA-865F5C20CA8C}"/>
+              </a:ext>
+            </a:extLst>
+          </p:cNvPr>
+          <p:cNvSpPr txBox="1"/>
+          <p:nvPr/>
+        </p:nvSpPr>
+        <p:spPr>
+          <a:xfrm>
+            <a:off x="5018809" y="3557974"/>
+            <a:ext cx="4978958" cy="646331"/>
+          </a:xfrm>
+          <a:prstGeom prst="rect">
+            <a:avLst/>
+          </a:prstGeom>
+          <a:noFill/>
+        </p:spPr>
+        <p:txBody>
+          <a:bodyPr wrap="square">
+            <a:spAutoFit/>
+          </a:bodyPr>
+          <a:lstStyle/>
+          <a:p>
+            <a:r>
+              <a:rPr lang="ja-JP" altLang="en-US"/>
+              <a:t>Fix the left side of a metal ring at high temperature and the right side at low temperature</a:t>
             </a:r>
           </a:p>
         </p:txBody>
@@ -18976,53 +18793,6 @@
       </p:cxnSp>
       <p:sp>
         <p:nvSpPr>
-          <p:cNvPr id="24" name="テキスト ボックス 23">
-            <a:extLst>
-              <a:ext uri="{FF2B5EF4-FFF2-40B4-BE49-F238E27FC236}">
-                <a16:creationId xmlns:a16="http://schemas.microsoft.com/office/drawing/2014/main" id="{21DAD823-1FAD-674F-866C-064A287EE53C}"/>
-              </a:ext>
-            </a:extLst>
-          </p:cNvPr>
-          <p:cNvSpPr txBox="1"/>
-          <p:nvPr/>
-        </p:nvSpPr>
-        <p:spPr>
-          <a:xfrm>
-            <a:off x="3152800" y="764704"/>
-            <a:ext cx="4801314" cy="646331"/>
-          </a:xfrm>
-          <a:prstGeom prst="rect">
-            <a:avLst/>
-          </a:prstGeom>
-          <a:noFill/>
-        </p:spPr>
-        <p:txBody>
-          <a:bodyPr wrap="square" rtlCol="0"/>
-          <a:lstStyle/>
-          <a:p>
-            <a:pPr>
-              <a:defRPr sz="1400"/>
-            </a:pPr>
-            <a:r>
-              <a:rPr kumimoji="1" lang="ja-JP" altLang="en-US" sz="1400"/>
-              <a:t>To compute the next-time state of a point,</a:t>
-            </a:r>
-            <a:endParaRPr kumimoji="1" lang="en-US" altLang="ja-JP"/>
-          </a:p>
-          <a:p>
-            <a:pPr>
-              <a:defRPr sz="1400"/>
-            </a:pPr>
-            <a:r>
-              <a:rPr kumimoji="1" lang="ja-JP" altLang="en-US" sz="1400"/>
-              <a:t>information from both neighboring points is needed</a:t>
-            </a:r>
-            <a:endParaRPr kumimoji="1" lang="en-US" altLang="ja-JP"/>
-          </a:p>
-        </p:txBody>
-      </p:sp>
-      <p:sp>
-        <p:nvSpPr>
           <p:cNvPr id="25" name="正方形/長方形 24">
             <a:extLst>
               <a:ext uri="{FF2B5EF4-FFF2-40B4-BE49-F238E27FC236}">
@@ -20232,8 +20002,8 @@
         </p:nvSpPr>
         <p:spPr>
           <a:xfrm>
-            <a:off x="5673080" y="3068960"/>
-            <a:ext cx="3185487" cy="369332"/>
+            <a:off x="6057595" y="3116994"/>
+            <a:ext cx="2795824" cy="369332"/>
           </a:xfrm>
           <a:prstGeom prst="rect">
             <a:avLst/>
@@ -21007,8 +20777,8 @@
         </p:nvSpPr>
         <p:spPr>
           <a:xfrm>
-            <a:off x="3368824" y="4077072"/>
-            <a:ext cx="2262158" cy="369332"/>
+            <a:off x="2792760" y="4125043"/>
+            <a:ext cx="3744416" cy="369332"/>
           </a:xfrm>
           <a:prstGeom prst="rect">
             <a:avLst/>
@@ -21998,10 +21768,10 @@
       </p:cxnSp>
       <p:sp>
         <p:nvSpPr>
-          <p:cNvPr id="105" name="テキスト ボックス 104">
-            <a:extLst>
-              <a:ext uri="{FF2B5EF4-FFF2-40B4-BE49-F238E27FC236}">
-                <a16:creationId xmlns:a16="http://schemas.microsoft.com/office/drawing/2014/main" id="{6AF6BF48-8659-1545-A94C-E7808D137839}"/>
+          <p:cNvPr id="15" name="テキスト ボックス 14">
+            <a:extLst>
+              <a:ext uri="{FF2B5EF4-FFF2-40B4-BE49-F238E27FC236}">
+                <a16:creationId xmlns:a16="http://schemas.microsoft.com/office/drawing/2014/main" id="{8C31E2A3-1F41-A13F-E9A1-FEA09FCC47CD}"/>
               </a:ext>
             </a:extLst>
           </p:cNvPr>
@@ -22010,8 +21780,8 @@
         </p:nvSpPr>
         <p:spPr>
           <a:xfrm>
-            <a:off x="1568624" y="6237312"/>
-            <a:ext cx="6647974" cy="369332"/>
+            <a:off x="3296277" y="699719"/>
+            <a:ext cx="5149112" cy="646331"/>
           </a:xfrm>
           <a:prstGeom prst="rect">
             <a:avLst/>
@@ -22019,16 +21789,54 @@
           <a:noFill/>
         </p:spPr>
         <p:txBody>
-          <a:bodyPr wrap="square" rtlCol="0">
-            <a:normAutofit/>
+          <a:bodyPr wrap="square">
+            <a:spAutoFit/>
           </a:bodyPr>
           <a:lstStyle/>
           <a:p>
-            <a:pPr>
-              <a:defRPr/>
-            </a:pPr>
             <a:r>
-              <a:rPr kumimoji="1" lang="ja-JP" altLang="en-US"/>
+              <a:rPr lang="ja-JP" altLang="en-US"/>
+              <a:t>To compute the next-time state of a point,</a:t>
+            </a:r>
+          </a:p>
+          <a:p>
+            <a:r>
+              <a:rPr lang="ja-JP" altLang="en-US"/>
+              <a:t>information from both neighboring points is needed</a:t>
+            </a:r>
+          </a:p>
+        </p:txBody>
+      </p:sp>
+      <p:sp>
+        <p:nvSpPr>
+          <p:cNvPr id="19" name="テキスト ボックス 18">
+            <a:extLst>
+              <a:ext uri="{FF2B5EF4-FFF2-40B4-BE49-F238E27FC236}">
+                <a16:creationId xmlns:a16="http://schemas.microsoft.com/office/drawing/2014/main" id="{647E87F7-67F3-6784-58CA-4F4BDC913ECD}"/>
+              </a:ext>
+            </a:extLst>
+          </p:cNvPr>
+          <p:cNvSpPr txBox="1"/>
+          <p:nvPr/>
+        </p:nvSpPr>
+        <p:spPr>
+          <a:xfrm>
+            <a:off x="485122" y="6263798"/>
+            <a:ext cx="8935756" cy="369332"/>
+          </a:xfrm>
+          <a:prstGeom prst="rect">
+            <a:avLst/>
+          </a:prstGeom>
+          <a:noFill/>
+        </p:spPr>
+        <p:txBody>
+          <a:bodyPr wrap="square">
+            <a:spAutoFit/>
+          </a:bodyPr>
+          <a:lstStyle/>
+          <a:p>
+            <a:r>
+              <a:rPr lang="ja-JP" altLang="en-US"/>
               <a:t>Using the received information, the next-time state of the boundary points can be computed</a:t>
             </a:r>
           </a:p>

</xml_diff>